<commit_message>
TpT 009 Spooky Tunes: drop the two-minor-keys requirement (owner); no key or form required, minor keys optional
Rubric Composition & Pacing back to the owner's May wording; requirements, checklist,
goals, day plans, teacher notes, deck slides/notes, UPLOAD.md and the metadata guide
updated. Send levels kept. gen.py --check scans outputs for any leftover key rule.

Co-Authored-By: Claude Sonnet 5.5 <noreply@anthropic.com>
Claude-Session: https://claude.ai/code/session_01UETtbiEyzCWi3eoMXW2Vud
</commit_message>
<xml_diff>
--- a/tpt/009-dmp1-spooky-tunes/spooky-tunes-intro-deck.pptx
+++ b/tpt/009-dmp1-spooky-tunes/spooky-tunes-intro-deck.pptx
@@ -587,7 +587,7 @@
           <a:lstStyle/>
           <a:p>
             <a:r>
-              <a:t>Day 2. The project uses two different minor keys: key 1 for measures 1–16 and key 2 for measures 17–32. The example is A minor (white keys only) moving to D minor (one flat, B-flat). The orange keys are the first chord: root, third and fifth (A C E, then D F A). The dots are the scale. Students fill in the Minor Key Map for their own two keys; the reference card has eight minor keys. Remind them the drone or bass must move to the new root at measure 17, or nobody hears the change.</a:t>
+              <a:t>Day 2. No key is required: students may work in any key, or in none, and atonal or sound-effect scores are fine. For anyone who wants a darker harmonic home, a minor key helps. The examples are A minor (white keys only) and D minor (one flat, B-flat). The orange keys are the first chord: root, third and fifth (A C E, D F A). The dots are the scale. The Minor Key Map and the reference card (eight minor keys) are optional reference pages. A student who changes key at a big moment should move the drone or bass too, or nobody hears the change.</a:t>
             </a:r>
           </a:p>
         </p:txBody>
@@ -657,7 +657,7 @@
           <a:lstStyle/>
           <a:p>
             <a:r>
-              <a:t>A score map for a 60-second clip at 128 BPM: 32 measures of 4/4 is exactly one minute, so every 4 measures is 7.5 seconds. Walk the numbered moments: the drone and wind fade in, close dry footsteps, a music-box melody with delay, a full measure of deliberate silence, then the key change on a visual cut at measure 17, a swelling reverb send and one impact with a long tail. Your own clip’s moments will differ: that is what the cue sheet is for.</a:t>
+              <a:t>A score map for a 60-second clip at 128 BPM: 32 measures of 4/4 is exactly one minute, so every 4 measures is 7.5 seconds. Walk the numbered moments: the drone and wind fade in, close dry footsteps, a music-box melody with delay, a full measure of deliberate silence, then a visual cut at measure 17 where the drone moves (this example happens to change key there; that is a choice, not a rule), a swelling reverb send and one impact with a long tail. Your own clip’s moments will differ: that is what the cue sheet is for.</a:t>
             </a:r>
           </a:p>
         </p:txBody>
@@ -727,7 +727,7 @@
           <a:lstStyle/>
           <a:p>
             <a:r>
-              <a:t>Hand out the project sheet and rubric. This is the brief: make it sound the way the video looks. Stress the three sound sources (at least one original microphone recording and one free download) and that both buses come before any composing. Atonal sound-effect layers are welcome on top of the two keys.</a:t>
+              <a:t>Hand out the project sheet and rubric. This is the brief: make it sound the way the video looks. Stress the three sound sources (at least one original microphone recording and one free download) and that both buses come before any composing. There is no chord progression, song form or key required: atonal and sound-effect scores are welcome.</a:t>
             </a:r>
           </a:p>
         </p:txBody>
@@ -797,7 +797,7 @@
           <a:lstStyle/>
           <a:p>
             <a:r>
-              <a:t>Walk the six days: Day 1 the bus demo and a working reverb bus; Day 2 the delay bus, the two keys and collecting at least 5 sounds; Days 3 and 4 importing the video, placing markers and composing in key 1, then key 2; Day 5 mix, reflection and submit; Day 6 presentations with the video. Students who need more time on routing get it on Day 2.</a:t>
+              <a:t>Walk the six days: Day 1 the bus demo and a working reverb bus; Day 2 the delay bus and collecting at least 5 sounds; Days 3 and 4 importing the video, placing markers and composing to the whole video; Day 5 mix, reflection and submit; Day 6 presentations with the video. Students who need more time on routing get it on Day 2.</a:t>
             </a:r>
           </a:p>
         </p:txBody>
@@ -937,7 +937,7 @@
           <a:lstStyle/>
           <a:p>
             <a:r>
-              <a:t>Five categories, each scored 2 to 5, for a total out of 25. Read the 5 column aloud so students know what great looks like: an atmosphere that serves the video at every moment, a score that lands its key change on a moment, buses used with intention, near sounds dry and far sounds wet, and a confident presentation that explains the sound choices.</a:t>
+              <a:t>Five categories, each scored 2 to 5, for a total out of 25. Read the 5 column aloud so students know what great looks like: an atmosphere that serves the video at every moment, a score where key moments are acknowledged and silence is a tool, buses used with intention, near sounds dry and far sounds wet, and a confident presentation that explains the sound choices.</a:t>
             </a:r>
           </a:p>
         </p:txBody>
@@ -1217,7 +1217,7 @@
           <a:lstStyle/>
           <a:p>
             <a:r>
-              <a:t>Connect their answers from the listening to four tools. Minor keys sound darker (they met major and minor earlier in the course; if not, the Minor Key Map covers it). Half steps are the smallest distance on the keyboard: play E and F together on the projector so they hear the rub. Space comes from reverb and delay. Silence is a sound too: a sound after silence feels enormous. Every one of these is a requirement or a rubric line.</a:t>
+              <a:t>Connect their answers from the listening to four tools. Minor keys sound darker (they met major and minor earlier in the course; if not, the Minor Key Map covers it). Half steps are the smallest distance on the keyboard: play E and F together on the projector so they hear the rub. Space comes from reverb and delay. Silence is a sound too: a sound after silence feels enormous. These are tools, not rules: no key is required, and a score with no key at all is fine.</a:t>
             </a:r>
           </a:p>
         </p:txBody>
@@ -4864,7 +4864,7 @@
                 </a:solidFill>
                 <a:latin typeface="Oswald"/>
               </a:rPr>
-              <a:t>TWO MINOR KEYS</a:t>
+              <a:t>OPTIONAL: TRY A MINOR KEY</a:t>
             </a:r>
           </a:p>
         </p:txBody>
@@ -5755,7 +5755,7 @@
                 </a:solidFill>
                 <a:latin typeface="Source Sans 3"/>
               </a:rPr>
-              <a:t>32 measures in two minor keys</a:t>
+              <a:t>32 measures: any key, or none</a:t>
             </a:r>
           </a:p>
         </p:txBody>
@@ -6387,7 +6387,7 @@
                 </a:solidFill>
                 <a:latin typeface="Source Sans 3"/>
               </a:rPr>
-              <a:t>Delay bus · pick two minor keys · collect 5+ sounds</a:t>
+              <a:t>Delay bus · collect 5+ sounds · mark your moments</a:t>
             </a:r>
           </a:p>
         </p:txBody>
@@ -6501,7 +6501,7 @@
                 </a:solidFill>
                 <a:latin typeface="Source Sans 3"/>
               </a:rPr>
-              <a:t>Import the video · markers · score key 1</a:t>
+              <a:t>Import the video · markers · start scoring</a:t>
             </a:r>
           </a:p>
         </p:txBody>
@@ -6615,7 +6615,7 @@
                 </a:solidFill>
                 <a:latin typeface="Source Sans 3"/>
               </a:rPr>
-              <a:t>Key 2 from measure 17 · rough mix</a:t>
+              <a:t>Score the whole video · rough mix</a:t>
             </a:r>
           </a:p>
         </p:txBody>
@@ -7332,7 +7332,7 @@
                 </a:solidFill>
                 <a:latin typeface="Source Sans 3"/>
               </a:rPr>
-              <a:t>Two minor keys, 32 measures, the whole video</a:t>
+              <a:t>Music for the whole video (32 measures)</a:t>
             </a:r>
           </a:p>
         </p:txBody>
@@ -8084,7 +8084,7 @@
                 </a:solidFill>
                 <a:latin typeface="Source Sans 3"/>
               </a:rPr>
-              <a:t>5 = The music follows the picture, silence is a tool, and the key change lands on a moment.</a:t>
+              <a:t>5 = The music serves the picture: key moments are acknowledged and silence is a tool.</a:t>
             </a:r>
           </a:p>
         </p:txBody>

</xml_diff>